<commit_message>
GreenWaste lab: one invented world, every method, one chart (Day 1 S3 first)
gw_lab.R builds a GreenWaste-shaped world of 20,000 businesses where the
true effect is known (-900 AED) and five sliders each switch on one
problem: costs rising anyway, joiners smaller (measured), joiners
different in something unmeasured, joiners' costs already falling faster,
something else changing at 58. lab() shows each method's estimate
against the truth and the 1,000 rule. Each problem breaks only the
methods it should; the randomised comparison survives all five.

Oct12 S3 gets two lab slides: the two naive comparisons with three
sliders at the end of section 3, and the same lab with the lottery
added at the end of section 4. The other method sessions will add DiD,
RDD and matching to the same chart. PDF and PowerPoint refreshed.

Co-Authored-By: Claude Opus 5.5 <noreply@anthropic.com>
</commit_message>
<xml_diff>
--- a/docs/exports/Oct12_session3.pptx
+++ b/docs/exports/Oct12_session3.pptx
@@ -44,6 +44,8 @@
     <p:sldId id="292" r:id="rId44"/>
     <p:sldId id="293" r:id="rId45"/>
     <p:sldId id="294" r:id="rId46"/>
+    <p:sldId id="295" r:id="rId47"/>
+    <p:sldId id="296" r:id="rId48"/>
   </p:sldIdLst>
   <p:sldSz cx="12192000" cy="6858000" type="screen4x3"/>
   <p:notesSz cx="6858000" cy="9144000"/>
@@ -666,7 +668,7 @@
           <a:lstStyle/>
           <a:p>
             <a:r>
-              <a:t>Paper (Oct12_session3_materials.docx): Hand out the AI handout (pack page 2, one per pair). The better prompt is printed below the flawed paragraph.</a:t>
+              <a:t>Paper (Oct12_session3_materials.docx): Tracker: record the interval counted by neighbourhood and whether it clears 1,000 AED.</a:t>
             </a:r>
           </a:p>
           <a:p/>
@@ -787,7 +789,7 @@
           <a:lstStyle/>
           <a:p>
             <a:r>
-              <a:t>If someone asks why we did not simply ask the AI to explain before-and-after bias: current models answer that general question well. The short prompt is closer to what people type when they are busy.</a:t>
+              <a:t>Same seed each time, so the subset at a given size is stable while you talk. Measured: 196 neighbourhoods 1,014 [935, 1,093]; 60 gives 1,022 [864, 1,179]; 20 gives 940 [591, 1,289]. Link back to Session 1: a study that is too small may fail to find a real effect.</a:t>
             </a:r>
           </a:p>
           <a:p/>
@@ -908,7 +910,7 @@
           <a:lstStyle/>
           <a:p>
             <a:r>
-              <a:t>OPTIONAL. If time is short, skip this slide and go straight to the questions on the next one. If you run it: give three minutes, then reveal the list and ask what the AI missed, what it added that is worth keeping, and whether anything it suggested was incorrect.</a:t>
+              <a:t>Paper (Oct12_session3_materials.docx): Hand out the AI handout (pack page 2, one per pair). The better prompt is printed below the flawed paragraph.</a:t>
             </a:r>
           </a:p>
           <a:p/>
@@ -1029,6 +1031,248 @@
           <a:lstStyle/>
           <a:p>
             <a:r>
+              <a:t>If someone asks why we did not simply ask the AI to explain before-and-after bias: current models answer that general question well. The short prompt is closer to what people type when they are busy.</a:t>
+            </a:r>
+          </a:p>
+          <a:p/>
+          <a:p>
+            <a:r>
+              <a:t>span.MJX_Assistive_MathML {</a:t>
+            </a:r>
+          </a:p>
+          <a:p>
+            <a:r>
+              <a:t>position:absolute!important;</a:t>
+            </a:r>
+          </a:p>
+          <a:p>
+            <a:r>
+              <a:t>clip: rect(1px, 1px, 1px, 1px);</a:t>
+            </a:r>
+          </a:p>
+          <a:p>
+            <a:r>
+              <a:t>padding: 1px 0 0 0!important;</a:t>
+            </a:r>
+          </a:p>
+          <a:p>
+            <a:r>
+              <a:t>border: 0!important;</a:t>
+            </a:r>
+          </a:p>
+          <a:p>
+            <a:r>
+              <a:t>height: 1px!important;</a:t>
+            </a:r>
+          </a:p>
+          <a:p>
+            <a:r>
+              <a:t>width: 1px!important;</a:t>
+            </a:r>
+          </a:p>
+          <a:p>
+            <a:r>
+              <a:t>overflow: hidden!important;</a:t>
+            </a:r>
+          </a:p>
+          <a:p>
+            <a:r>
+              <a:t>display:block!important;</a:t>
+            </a:r>
+          </a:p>
+          <a:p>
+            <a:r>
+              <a:t>}</a:t>
+            </a:r>
+          </a:p>
+        </p:txBody>
+      </p:sp>
+      <p:sp>
+        <p:nvSpPr>
+          <p:cNvPr id="4" name="Slide Number Placeholder 3"/>
+          <p:cNvSpPr>
+            <a:spLocks noGrp="1"/>
+          </p:cNvSpPr>
+          <p:nvPr>
+            <p:ph type="sldNum" idx="5" sz="quarter"/>
+          </p:nvPr>
+        </p:nvSpPr>
+        <p:spPr/>
+      </p:sp>
+    </p:spTree>
+  </p:cSld>
+  <p:clrMapOvr>
+    <a:masterClrMapping/>
+  </p:clrMapOvr>
+</p:notes>
+</file>
+
+<file path=ppt/notesSlides/notesSlide14.xml><?xml version="1.0" encoding="utf-8"?>
+<p:notes xmlns:a="http://schemas.openxmlformats.org/drawingml/2006/main" xmlns:p="http://schemas.openxmlformats.org/presentationml/2006/main" xmlns:r="http://schemas.openxmlformats.org/officeDocument/2006/relationships">
+  <p:cSld>
+    <p:spTree>
+      <p:nvGrpSpPr>
+        <p:cNvPr id="1" name=""/>
+        <p:cNvGrpSpPr/>
+        <p:nvPr/>
+      </p:nvGrpSpPr>
+      <p:grpSpPr>
+        <a:xfrm>
+          <a:off x="0" y="0"/>
+          <a:ext cx="0" cy="0"/>
+          <a:chOff x="0" y="0"/>
+          <a:chExt cx="0" cy="0"/>
+        </a:xfrm>
+      </p:grpSpPr>
+      <p:sp>
+        <p:nvSpPr>
+          <p:cNvPr id="2" name="Slide Image Placeholder 1"/>
+          <p:cNvSpPr>
+            <a:spLocks noGrp="1"/>
+          </p:cNvSpPr>
+          <p:nvPr>
+            <p:ph type="sldImg" idx="2"/>
+          </p:nvPr>
+        </p:nvSpPr>
+        <p:spPr/>
+      </p:sp>
+      <p:sp>
+        <p:nvSpPr>
+          <p:cNvPr id="3" name="Notes Placeholder 2"/>
+          <p:cNvSpPr>
+            <a:spLocks noGrp="1"/>
+          </p:cNvSpPr>
+          <p:nvPr>
+            <p:ph type="body" idx="3" sz="quarter"/>
+          </p:nvPr>
+        </p:nvSpPr>
+        <p:spPr/>
+        <p:txBody>
+          <a:bodyPr/>
+          <a:lstStyle/>
+          <a:p>
+            <a:r>
+              <a:t>OPTIONAL. If time is short, skip this slide and go straight to the questions on the next one. If you run it: give three minutes, then reveal the list and ask what the AI missed, what it added that is worth keeping, and whether anything it suggested was incorrect.</a:t>
+            </a:r>
+          </a:p>
+          <a:p/>
+          <a:p>
+            <a:r>
+              <a:t>span.MJX_Assistive_MathML {</a:t>
+            </a:r>
+          </a:p>
+          <a:p>
+            <a:r>
+              <a:t>position:absolute!important;</a:t>
+            </a:r>
+          </a:p>
+          <a:p>
+            <a:r>
+              <a:t>clip: rect(1px, 1px, 1px, 1px);</a:t>
+            </a:r>
+          </a:p>
+          <a:p>
+            <a:r>
+              <a:t>padding: 1px 0 0 0!important;</a:t>
+            </a:r>
+          </a:p>
+          <a:p>
+            <a:r>
+              <a:t>border: 0!important;</a:t>
+            </a:r>
+          </a:p>
+          <a:p>
+            <a:r>
+              <a:t>height: 1px!important;</a:t>
+            </a:r>
+          </a:p>
+          <a:p>
+            <a:r>
+              <a:t>width: 1px!important;</a:t>
+            </a:r>
+          </a:p>
+          <a:p>
+            <a:r>
+              <a:t>overflow: hidden!important;</a:t>
+            </a:r>
+          </a:p>
+          <a:p>
+            <a:r>
+              <a:t>display:block!important;</a:t>
+            </a:r>
+          </a:p>
+          <a:p>
+            <a:r>
+              <a:t>}</a:t>
+            </a:r>
+          </a:p>
+        </p:txBody>
+      </p:sp>
+      <p:sp>
+        <p:nvSpPr>
+          <p:cNvPr id="4" name="Slide Number Placeholder 3"/>
+          <p:cNvSpPr>
+            <a:spLocks noGrp="1"/>
+          </p:cNvSpPr>
+          <p:nvPr>
+            <p:ph type="sldNum" idx="5" sz="quarter"/>
+          </p:nvPr>
+        </p:nvSpPr>
+        <p:spPr/>
+      </p:sp>
+    </p:spTree>
+  </p:cSld>
+  <p:clrMapOvr>
+    <a:masterClrMapping/>
+  </p:clrMapOvr>
+</p:notes>
+</file>
+
+<file path=ppt/notesSlides/notesSlide15.xml><?xml version="1.0" encoding="utf-8"?>
+<p:notes xmlns:a="http://schemas.openxmlformats.org/drawingml/2006/main" xmlns:p="http://schemas.openxmlformats.org/presentationml/2006/main" xmlns:r="http://schemas.openxmlformats.org/officeDocument/2006/relationships">
+  <p:cSld>
+    <p:spTree>
+      <p:nvGrpSpPr>
+        <p:cNvPr id="1" name=""/>
+        <p:cNvGrpSpPr/>
+        <p:nvPr/>
+      </p:nvGrpSpPr>
+      <p:grpSpPr>
+        <a:xfrm>
+          <a:off x="0" y="0"/>
+          <a:ext cx="0" cy="0"/>
+          <a:chOff x="0" y="0"/>
+          <a:chExt cx="0" cy="0"/>
+        </a:xfrm>
+      </p:grpSpPr>
+      <p:sp>
+        <p:nvSpPr>
+          <p:cNvPr id="2" name="Slide Image Placeholder 1"/>
+          <p:cNvSpPr>
+            <a:spLocks noGrp="1"/>
+          </p:cNvSpPr>
+          <p:nvPr>
+            <p:ph type="sldImg" idx="2"/>
+          </p:nvPr>
+        </p:nvSpPr>
+        <p:spPr/>
+      </p:sp>
+      <p:sp>
+        <p:nvSpPr>
+          <p:cNvPr id="3" name="Notes Placeholder 2"/>
+          <p:cNvSpPr>
+            <a:spLocks noGrp="1"/>
+          </p:cNvSpPr>
+          <p:nvPr>
+            <p:ph type="body" idx="3" sz="quarter"/>
+          </p:nvPr>
+        </p:nvSpPr>
+        <p:spPr/>
+        <p:txBody>
+          <a:bodyPr/>
+          <a:lstStyle/>
+          <a:p>
+            <a:r>
               <a:t>Paper (Oct12_session3_materials.docx): Hand out the take-away cards (pack page 3). Give a minute to fill in “On my desk” on the card, then take two or three examples from the room.</a:t>
             </a:r>
           </a:p>
@@ -1513,7 +1757,7 @@
           <a:lstStyle/>
           <a:p>
             <a:r>
-              <a:t>Paper (Oct12_session3_materials.docx): Tracker: record the largest gap after five draws, then the gap when officials pick.</a:t>
+              <a:t>About 5 minutes. With every slider at zero both estimates sit on the truth: a naive comparison is only wrong when the world has these problems, and the real GreenWaste had them. Move one slider at a time and take a call first. “Costs rise anyway” moves only before-and-after (towards zero, as in the real data, where costs rose about 150 AED). The two “joiners differ” sliders move only with-and-without, and make it look bigger than the truth, as the 1,447 did. Leave the sliders where the room ends up; the lab comes back after the lottery.</a:t>
             </a:r>
           </a:p>
           <a:p/>
@@ -1634,7 +1878,7 @@
           <a:lstStyle/>
           <a:p>
             <a:r>
-              <a:t>At 4 the gaps run to hundreds of AED either way; at ~196 almost every draw starts within a few dozen. This is “two people versus two crowds” from Module 1, seen in the data. The same holds for characteristics nobody measured.</a:t>
+              <a:t>Paper (Oct12_session3_materials.docx): Tracker: record the largest gap after five draws, then the gap when officials pick.</a:t>
             </a:r>
           </a:p>
           <a:p/>
@@ -1755,7 +1999,7 @@
           <a:lstStyle/>
           <a:p>
             <a:r>
-              <a:t>This asks the room to apply what the two lottery slides showed to a result they might be handed. Expect a split between A and B; let one person from each argue before revealing.</a:t>
+              <a:t>At 4 the gaps run to hundreds of AED either way; at ~196 almost every draw starts within a few dozen. This is “two people versus two crowds” from Module 1, seen in the data. The same holds for characteristics nobody measured.</a:t>
             </a:r>
           </a:p>
           <a:p/>
@@ -1876,7 +2120,7 @@
           <a:lstStyle/>
           <a:p>
             <a:r>
-              <a:t>Paper (Oct12_session3_materials.docx): Tracker: record the interval counted by neighbourhood and whether it clears 1,000 AED.</a:t>
+              <a:t>This asks the room to apply what the two lottery slides showed to a result they might be handed. Expect a split between A and B; let one person from each argue before revealing.</a:t>
             </a:r>
           </a:p>
           <a:p/>
@@ -1997,7 +2241,7 @@
           <a:lstStyle/>
           <a:p>
             <a:r>
-              <a:t>Same seed each time, so the subset at a given size is stable while you talk. Measured: 196 neighbourhoods 1,014 [935, 1,093]; 60 gives 1,022 [864, 1,179]; 20 gives 940 [591, 1,289]. Link back to Session 1: a study that is too small may fail to find a real effect.</a:t>
+              <a:t>About 3 minutes. The sliders start with all three problems switched on. This chart comes back in every method session with one more method added: difference-in-differences tomorrow morning, then regression discontinuity, then matching. Each new method will survive some sliders and not others; only the lottery survives them all.</a:t>
             </a:r>
           </a:p>
           <a:p/>
@@ -6472,6 +6716,90 @@
 </p:sld>
 </file>
 
+<file path=ppt/slides/slide40.xml><?xml version="1.0" encoding="utf-8"?>
+<p:sld xmlns:a="http://schemas.openxmlformats.org/drawingml/2006/main" xmlns:p="http://schemas.openxmlformats.org/presentationml/2006/main" xmlns:r="http://schemas.openxmlformats.org/officeDocument/2006/relationships">
+  <p:cSld>
+    <p:spTree>
+      <p:nvGrpSpPr>
+        <p:cNvPr id="1" name=""/>
+        <p:cNvGrpSpPr/>
+        <p:nvPr/>
+      </p:nvGrpSpPr>
+      <p:grpSpPr/>
+      <p:pic>
+        <p:nvPicPr>
+          <p:cNvPr id="2" name="Picture 1" descr="s040.jpg"/>
+          <p:cNvPicPr>
+            <a:picLocks noChangeAspect="1"/>
+          </p:cNvPicPr>
+          <p:nvPr/>
+        </p:nvPicPr>
+        <p:blipFill>
+          <a:blip r:embed="rId2"/>
+          <a:stretch>
+            <a:fillRect/>
+          </a:stretch>
+        </p:blipFill>
+        <p:spPr>
+          <a:xfrm>
+            <a:off x="0" y="0"/>
+            <a:ext cx="12192000" cy="6858000"/>
+          </a:xfrm>
+          <a:prstGeom prst="rect">
+            <a:avLst/>
+          </a:prstGeom>
+        </p:spPr>
+      </p:pic>
+    </p:spTree>
+  </p:cSld>
+  <p:clrMapOvr>
+    <a:masterClrMapping/>
+  </p:clrMapOvr>
+</p:sld>
+</file>
+
+<file path=ppt/slides/slide41.xml><?xml version="1.0" encoding="utf-8"?>
+<p:sld xmlns:a="http://schemas.openxmlformats.org/drawingml/2006/main" xmlns:p="http://schemas.openxmlformats.org/presentationml/2006/main" xmlns:r="http://schemas.openxmlformats.org/officeDocument/2006/relationships">
+  <p:cSld>
+    <p:spTree>
+      <p:nvGrpSpPr>
+        <p:cNvPr id="1" name=""/>
+        <p:cNvGrpSpPr/>
+        <p:nvPr/>
+      </p:nvGrpSpPr>
+      <p:grpSpPr/>
+      <p:pic>
+        <p:nvPicPr>
+          <p:cNvPr id="2" name="Picture 1" descr="s041.jpg"/>
+          <p:cNvPicPr>
+            <a:picLocks noChangeAspect="1"/>
+          </p:cNvPicPr>
+          <p:nvPr/>
+        </p:nvPicPr>
+        <p:blipFill>
+          <a:blip r:embed="rId2"/>
+          <a:stretch>
+            <a:fillRect/>
+          </a:stretch>
+        </p:blipFill>
+        <p:spPr>
+          <a:xfrm>
+            <a:off x="0" y="0"/>
+            <a:ext cx="12192000" cy="6858000"/>
+          </a:xfrm>
+          <a:prstGeom prst="rect">
+            <a:avLst/>
+          </a:prstGeom>
+        </p:spPr>
+      </p:pic>
+    </p:spTree>
+  </p:cSld>
+  <p:clrMapOvr>
+    <a:masterClrMapping/>
+  </p:clrMapOvr>
+</p:sld>
+</file>
+
 <file path=ppt/slides/slide5.xml><?xml version="1.0" encoding="utf-8"?>
 <p:sld xmlns:a="http://schemas.openxmlformats.org/drawingml/2006/main" xmlns:p="http://schemas.openxmlformats.org/presentationml/2006/main" xmlns:r="http://schemas.openxmlformats.org/officeDocument/2006/relationships">
   <p:cSld>

</xml_diff>